<commit_message>
docs: the deck numbers its pages "N / 19"
Slides 2 to 19 carry "N / 19" at the bottom right, 30 px semibold, dark
grey on light slides and near-white on the dark one, so the number reads at
phone size; the source footer narrows to 1440 px to leave it room. deck.html
and deck.pdf are rebuilt with the README recipe, and deck.pptx is the deck's
own export again (PowerPoint, basic fonts).
</commit_message>
<xml_diff>
--- a/docs/presentations/access-tracking-intro/deck.pptx
+++ b/docs/presentations/access-tracking-intro/deck.pptx
@@ -3142,7 +3142,7 @@
         <p:spPr>
           <a:xfrm>
             <a:off x="812800" y="6238280"/>
-            <a:ext cx="9941560" cy="238720"/>
+            <a:ext cx="9418320" cy="238720"/>
           </a:xfrm>
           <a:prstGeom prst="rect">
             <a:avLst/>
@@ -3185,8 +3185,8 @@
         </p:nvSpPr>
         <p:spPr>
           <a:xfrm>
-            <a:off x="10566400" y="6238280"/>
-            <a:ext cx="812800" cy="238720"/>
+            <a:off x="10058400" y="6210300"/>
+            <a:ext cx="1320800" cy="292100"/>
           </a:xfrm>
           <a:prstGeom prst="rect">
             <a:avLst/>
@@ -3202,22 +3202,22 @@
           <a:p>
             <a:pPr algn="r" indent="0" marL="0">
               <a:lnSpc>
-                <a:spcPts val="1680"/>
-              </a:lnSpc>
-              <a:buNone/>
-            </a:pPr>
-            <a:r>
-              <a:rPr lang="en-US" sz="1200" dirty="0">
-                <a:solidFill>
-                  <a:srgbClr val="5F6A77"/>
-                </a:solidFill>
-                <a:latin typeface="Arial" pitchFamily="34" charset="0"/>
-                <a:ea typeface="Arial" pitchFamily="34" charset="-122"/>
-                <a:cs typeface="Arial" pitchFamily="34" charset="-120"/>
-              </a:rPr>
-              <a:t>10</a:t>
-            </a:r>
-            <a:endParaRPr lang="en-US" sz="1200" dirty="0"/>
+                <a:spcPts val="2100"/>
+              </a:lnSpc>
+              <a:buNone/>
+            </a:pPr>
+            <a:r>
+              <a:rPr lang="en-US" sz="1500" b="1" dirty="0">
+                <a:solidFill>
+                  <a:srgbClr val="3E4A57"/>
+                </a:solidFill>
+                <a:latin typeface="Arial" pitchFamily="34" charset="0"/>
+                <a:ea typeface="Arial" pitchFamily="34" charset="-122"/>
+                <a:cs typeface="Arial" pitchFamily="34" charset="-120"/>
+              </a:rPr>
+              <a:t>10 / 19</a:t>
+            </a:r>
+            <a:endParaRPr lang="en-US" sz="1500" dirty="0"/>
           </a:p>
         </p:txBody>
       </p:sp>
@@ -3393,8 +3393,8 @@
         </p:nvSpPr>
         <p:spPr>
           <a:xfrm>
-            <a:off x="10566400" y="6238280"/>
-            <a:ext cx="812800" cy="238720"/>
+            <a:off x="10058400" y="6210300"/>
+            <a:ext cx="1320800" cy="292100"/>
           </a:xfrm>
           <a:prstGeom prst="rect">
             <a:avLst/>
@@ -3410,22 +3410,22 @@
           <a:p>
             <a:pPr algn="r" indent="0" marL="0">
               <a:lnSpc>
-                <a:spcPts val="1680"/>
-              </a:lnSpc>
-              <a:buNone/>
-            </a:pPr>
-            <a:r>
-              <a:rPr lang="en-US" sz="1200" dirty="0">
-                <a:solidFill>
-                  <a:srgbClr val="9AA5B3"/>
-                </a:solidFill>
-                <a:latin typeface="Arial" pitchFamily="34" charset="0"/>
-                <a:ea typeface="Arial" pitchFamily="34" charset="-122"/>
-                <a:cs typeface="Arial" pitchFamily="34" charset="-120"/>
-              </a:rPr>
-              <a:t>11</a:t>
-            </a:r>
-            <a:endParaRPr lang="en-US" sz="1200" dirty="0"/>
+                <a:spcPts val="2100"/>
+              </a:lnSpc>
+              <a:buNone/>
+            </a:pPr>
+            <a:r>
+              <a:rPr lang="en-US" sz="1500" b="1" dirty="0">
+                <a:solidFill>
+                  <a:srgbClr val="E5E9EF"/>
+                </a:solidFill>
+                <a:latin typeface="Arial" pitchFamily="34" charset="0"/>
+                <a:ea typeface="Arial" pitchFamily="34" charset="-122"/>
+                <a:cs typeface="Arial" pitchFamily="34" charset="-120"/>
+              </a:rPr>
+              <a:t>11 / 19</a:t>
+            </a:r>
+            <a:endParaRPr lang="en-US" sz="1500" dirty="0"/>
           </a:p>
         </p:txBody>
       </p:sp>
@@ -4690,7 +4690,7 @@
         <p:spPr>
           <a:xfrm>
             <a:off x="812800" y="6238280"/>
-            <a:ext cx="9941560" cy="238720"/>
+            <a:ext cx="9418320" cy="238720"/>
           </a:xfrm>
           <a:prstGeom prst="rect">
             <a:avLst/>
@@ -4733,8 +4733,8 @@
         </p:nvSpPr>
         <p:spPr>
           <a:xfrm>
-            <a:off x="10566400" y="6238280"/>
-            <a:ext cx="812800" cy="238720"/>
+            <a:off x="10058400" y="6210300"/>
+            <a:ext cx="1320800" cy="292100"/>
           </a:xfrm>
           <a:prstGeom prst="rect">
             <a:avLst/>
@@ -4750,22 +4750,22 @@
           <a:p>
             <a:pPr algn="r" indent="0" marL="0">
               <a:lnSpc>
-                <a:spcPts val="1680"/>
-              </a:lnSpc>
-              <a:buNone/>
-            </a:pPr>
-            <a:r>
-              <a:rPr lang="en-US" sz="1200" dirty="0">
-                <a:solidFill>
-                  <a:srgbClr val="5F6A77"/>
-                </a:solidFill>
-                <a:latin typeface="Arial" pitchFamily="34" charset="0"/>
-                <a:ea typeface="Arial" pitchFamily="34" charset="-122"/>
-                <a:cs typeface="Arial" pitchFamily="34" charset="-120"/>
-              </a:rPr>
-              <a:t>12</a:t>
-            </a:r>
-            <a:endParaRPr lang="en-US" sz="1200" dirty="0"/>
+                <a:spcPts val="2100"/>
+              </a:lnSpc>
+              <a:buNone/>
+            </a:pPr>
+            <a:r>
+              <a:rPr lang="en-US" sz="1500" b="1" dirty="0">
+                <a:solidFill>
+                  <a:srgbClr val="3E4A57"/>
+                </a:solidFill>
+                <a:latin typeface="Arial" pitchFamily="34" charset="0"/>
+                <a:ea typeface="Arial" pitchFamily="34" charset="-122"/>
+                <a:cs typeface="Arial" pitchFamily="34" charset="-120"/>
+              </a:rPr>
+              <a:t>12 / 19</a:t>
+            </a:r>
+            <a:endParaRPr lang="en-US" sz="1500" dirty="0"/>
           </a:p>
         </p:txBody>
       </p:sp>
@@ -4969,7 +4969,7 @@
         <p:spPr>
           <a:xfrm>
             <a:off x="812800" y="6238280"/>
-            <a:ext cx="9941560" cy="238720"/>
+            <a:ext cx="9418320" cy="238720"/>
           </a:xfrm>
           <a:prstGeom prst="rect">
             <a:avLst/>
@@ -5012,8 +5012,8 @@
         </p:nvSpPr>
         <p:spPr>
           <a:xfrm>
-            <a:off x="10566400" y="6238280"/>
-            <a:ext cx="812800" cy="238720"/>
+            <a:off x="10058400" y="6210300"/>
+            <a:ext cx="1320800" cy="292100"/>
           </a:xfrm>
           <a:prstGeom prst="rect">
             <a:avLst/>
@@ -5029,22 +5029,22 @@
           <a:p>
             <a:pPr algn="r" indent="0" marL="0">
               <a:lnSpc>
-                <a:spcPts val="1680"/>
-              </a:lnSpc>
-              <a:buNone/>
-            </a:pPr>
-            <a:r>
-              <a:rPr lang="en-US" sz="1200" dirty="0">
-                <a:solidFill>
-                  <a:srgbClr val="5F6A77"/>
-                </a:solidFill>
-                <a:latin typeface="Arial" pitchFamily="34" charset="0"/>
-                <a:ea typeface="Arial" pitchFamily="34" charset="-122"/>
-                <a:cs typeface="Arial" pitchFamily="34" charset="-120"/>
-              </a:rPr>
-              <a:t>13</a:t>
-            </a:r>
-            <a:endParaRPr lang="en-US" sz="1200" dirty="0"/>
+                <a:spcPts val="2100"/>
+              </a:lnSpc>
+              <a:buNone/>
+            </a:pPr>
+            <a:r>
+              <a:rPr lang="en-US" sz="1500" b="1" dirty="0">
+                <a:solidFill>
+                  <a:srgbClr val="3E4A57"/>
+                </a:solidFill>
+                <a:latin typeface="Arial" pitchFamily="34" charset="0"/>
+                <a:ea typeface="Arial" pitchFamily="34" charset="-122"/>
+                <a:cs typeface="Arial" pitchFamily="34" charset="-120"/>
+              </a:rPr>
+              <a:t>13 / 19</a:t>
+            </a:r>
+            <a:endParaRPr lang="en-US" sz="1500" dirty="0"/>
           </a:p>
         </p:txBody>
       </p:sp>
@@ -5248,7 +5248,7 @@
         <p:spPr>
           <a:xfrm>
             <a:off x="812800" y="6238280"/>
-            <a:ext cx="9941560" cy="238720"/>
+            <a:ext cx="9418320" cy="238720"/>
           </a:xfrm>
           <a:prstGeom prst="rect">
             <a:avLst/>
@@ -5291,8 +5291,8 @@
         </p:nvSpPr>
         <p:spPr>
           <a:xfrm>
-            <a:off x="10566400" y="6238280"/>
-            <a:ext cx="812800" cy="238720"/>
+            <a:off x="10058400" y="6210300"/>
+            <a:ext cx="1320800" cy="292100"/>
           </a:xfrm>
           <a:prstGeom prst="rect">
             <a:avLst/>
@@ -5308,22 +5308,22 @@
           <a:p>
             <a:pPr algn="r" indent="0" marL="0">
               <a:lnSpc>
-                <a:spcPts val="1680"/>
-              </a:lnSpc>
-              <a:buNone/>
-            </a:pPr>
-            <a:r>
-              <a:rPr lang="en-US" sz="1200" dirty="0">
-                <a:solidFill>
-                  <a:srgbClr val="5F6A77"/>
-                </a:solidFill>
-                <a:latin typeface="Arial" pitchFamily="34" charset="0"/>
-                <a:ea typeface="Arial" pitchFamily="34" charset="-122"/>
-                <a:cs typeface="Arial" pitchFamily="34" charset="-120"/>
-              </a:rPr>
-              <a:t>14</a:t>
-            </a:r>
-            <a:endParaRPr lang="en-US" sz="1200" dirty="0"/>
+                <a:spcPts val="2100"/>
+              </a:lnSpc>
+              <a:buNone/>
+            </a:pPr>
+            <a:r>
+              <a:rPr lang="en-US" sz="1500" b="1" dirty="0">
+                <a:solidFill>
+                  <a:srgbClr val="3E4A57"/>
+                </a:solidFill>
+                <a:latin typeface="Arial" pitchFamily="34" charset="0"/>
+                <a:ea typeface="Arial" pitchFamily="34" charset="-122"/>
+                <a:cs typeface="Arial" pitchFamily="34" charset="-120"/>
+              </a:rPr>
+              <a:t>14 / 19</a:t>
+            </a:r>
+            <a:endParaRPr lang="en-US" sz="1500" dirty="0"/>
           </a:p>
         </p:txBody>
       </p:sp>
@@ -5527,7 +5527,7 @@
         <p:spPr>
           <a:xfrm>
             <a:off x="812800" y="6238280"/>
-            <a:ext cx="9941560" cy="238720"/>
+            <a:ext cx="9418320" cy="238720"/>
           </a:xfrm>
           <a:prstGeom prst="rect">
             <a:avLst/>
@@ -5570,8 +5570,8 @@
         </p:nvSpPr>
         <p:spPr>
           <a:xfrm>
-            <a:off x="10566400" y="6238280"/>
-            <a:ext cx="812800" cy="238720"/>
+            <a:off x="10058400" y="6210300"/>
+            <a:ext cx="1320800" cy="292100"/>
           </a:xfrm>
           <a:prstGeom prst="rect">
             <a:avLst/>
@@ -5587,22 +5587,22 @@
           <a:p>
             <a:pPr algn="r" indent="0" marL="0">
               <a:lnSpc>
-                <a:spcPts val="1680"/>
-              </a:lnSpc>
-              <a:buNone/>
-            </a:pPr>
-            <a:r>
-              <a:rPr lang="en-US" sz="1200" dirty="0">
-                <a:solidFill>
-                  <a:srgbClr val="5F6A77"/>
-                </a:solidFill>
-                <a:latin typeface="Arial" pitchFamily="34" charset="0"/>
-                <a:ea typeface="Arial" pitchFamily="34" charset="-122"/>
-                <a:cs typeface="Arial" pitchFamily="34" charset="-120"/>
-              </a:rPr>
-              <a:t>15</a:t>
-            </a:r>
-            <a:endParaRPr lang="en-US" sz="1200" dirty="0"/>
+                <a:spcPts val="2100"/>
+              </a:lnSpc>
+              <a:buNone/>
+            </a:pPr>
+            <a:r>
+              <a:rPr lang="en-US" sz="1500" b="1" dirty="0">
+                <a:solidFill>
+                  <a:srgbClr val="3E4A57"/>
+                </a:solidFill>
+                <a:latin typeface="Arial" pitchFamily="34" charset="0"/>
+                <a:ea typeface="Arial" pitchFamily="34" charset="-122"/>
+                <a:cs typeface="Arial" pitchFamily="34" charset="-120"/>
+              </a:rPr>
+              <a:t>15 / 19</a:t>
+            </a:r>
+            <a:endParaRPr lang="en-US" sz="1500" dirty="0"/>
           </a:p>
         </p:txBody>
       </p:sp>
@@ -5806,7 +5806,7 @@
         <p:spPr>
           <a:xfrm>
             <a:off x="812800" y="6238280"/>
-            <a:ext cx="9941560" cy="238720"/>
+            <a:ext cx="9418320" cy="238720"/>
           </a:xfrm>
           <a:prstGeom prst="rect">
             <a:avLst/>
@@ -5849,8 +5849,8 @@
         </p:nvSpPr>
         <p:spPr>
           <a:xfrm>
-            <a:off x="10566400" y="6238280"/>
-            <a:ext cx="812800" cy="238720"/>
+            <a:off x="10058400" y="6210300"/>
+            <a:ext cx="1320800" cy="292100"/>
           </a:xfrm>
           <a:prstGeom prst="rect">
             <a:avLst/>
@@ -5866,22 +5866,22 @@
           <a:p>
             <a:pPr algn="r" indent="0" marL="0">
               <a:lnSpc>
-                <a:spcPts val="1680"/>
-              </a:lnSpc>
-              <a:buNone/>
-            </a:pPr>
-            <a:r>
-              <a:rPr lang="en-US" sz="1200" dirty="0">
-                <a:solidFill>
-                  <a:srgbClr val="5F6A77"/>
-                </a:solidFill>
-                <a:latin typeface="Arial" pitchFamily="34" charset="0"/>
-                <a:ea typeface="Arial" pitchFamily="34" charset="-122"/>
-                <a:cs typeface="Arial" pitchFamily="34" charset="-120"/>
-              </a:rPr>
-              <a:t>16</a:t>
-            </a:r>
-            <a:endParaRPr lang="en-US" sz="1200" dirty="0"/>
+                <a:spcPts val="2100"/>
+              </a:lnSpc>
+              <a:buNone/>
+            </a:pPr>
+            <a:r>
+              <a:rPr lang="en-US" sz="1500" b="1" dirty="0">
+                <a:solidFill>
+                  <a:srgbClr val="3E4A57"/>
+                </a:solidFill>
+                <a:latin typeface="Arial" pitchFamily="34" charset="0"/>
+                <a:ea typeface="Arial" pitchFamily="34" charset="-122"/>
+                <a:cs typeface="Arial" pitchFamily="34" charset="-120"/>
+              </a:rPr>
+              <a:t>16 / 19</a:t>
+            </a:r>
+            <a:endParaRPr lang="en-US" sz="1500" dirty="0"/>
           </a:p>
         </p:txBody>
       </p:sp>
@@ -6354,7 +6354,7 @@
         <p:spPr>
           <a:xfrm>
             <a:off x="812800" y="6238280"/>
-            <a:ext cx="9941560" cy="238720"/>
+            <a:ext cx="9418320" cy="238720"/>
           </a:xfrm>
           <a:prstGeom prst="rect">
             <a:avLst/>
@@ -6397,8 +6397,8 @@
         </p:nvSpPr>
         <p:spPr>
           <a:xfrm>
-            <a:off x="10566400" y="6238280"/>
-            <a:ext cx="812800" cy="238720"/>
+            <a:off x="10058400" y="6210300"/>
+            <a:ext cx="1320800" cy="292100"/>
           </a:xfrm>
           <a:prstGeom prst="rect">
             <a:avLst/>
@@ -6414,22 +6414,22 @@
           <a:p>
             <a:pPr algn="r" indent="0" marL="0">
               <a:lnSpc>
-                <a:spcPts val="1680"/>
-              </a:lnSpc>
-              <a:buNone/>
-            </a:pPr>
-            <a:r>
-              <a:rPr lang="en-US" sz="1200" dirty="0">
-                <a:solidFill>
-                  <a:srgbClr val="5F6A77"/>
-                </a:solidFill>
-                <a:latin typeface="Arial" pitchFamily="34" charset="0"/>
-                <a:ea typeface="Arial" pitchFamily="34" charset="-122"/>
-                <a:cs typeface="Arial" pitchFamily="34" charset="-120"/>
-              </a:rPr>
-              <a:t>17</a:t>
-            </a:r>
-            <a:endParaRPr lang="en-US" sz="1200" dirty="0"/>
+                <a:spcPts val="2100"/>
+              </a:lnSpc>
+              <a:buNone/>
+            </a:pPr>
+            <a:r>
+              <a:rPr lang="en-US" sz="1500" b="1" dirty="0">
+                <a:solidFill>
+                  <a:srgbClr val="3E4A57"/>
+                </a:solidFill>
+                <a:latin typeface="Arial" pitchFamily="34" charset="0"/>
+                <a:ea typeface="Arial" pitchFamily="34" charset="-122"/>
+                <a:cs typeface="Arial" pitchFamily="34" charset="-120"/>
+              </a:rPr>
+              <a:t>17 / 19</a:t>
+            </a:r>
+            <a:endParaRPr lang="en-US" sz="1500" dirty="0"/>
           </a:p>
         </p:txBody>
       </p:sp>
@@ -7546,7 +7546,7 @@
         <p:spPr>
           <a:xfrm>
             <a:off x="812800" y="6238280"/>
-            <a:ext cx="9941560" cy="238720"/>
+            <a:ext cx="9418320" cy="238720"/>
           </a:xfrm>
           <a:prstGeom prst="rect">
             <a:avLst/>
@@ -7589,8 +7589,8 @@
         </p:nvSpPr>
         <p:spPr>
           <a:xfrm>
-            <a:off x="10566400" y="6238280"/>
-            <a:ext cx="812800" cy="238720"/>
+            <a:off x="10058400" y="6210300"/>
+            <a:ext cx="1320800" cy="292100"/>
           </a:xfrm>
           <a:prstGeom prst="rect">
             <a:avLst/>
@@ -7606,22 +7606,22 @@
           <a:p>
             <a:pPr algn="r" indent="0" marL="0">
               <a:lnSpc>
-                <a:spcPts val="1680"/>
-              </a:lnSpc>
-              <a:buNone/>
-            </a:pPr>
-            <a:r>
-              <a:rPr lang="en-US" sz="1200" dirty="0">
-                <a:solidFill>
-                  <a:srgbClr val="5F6A77"/>
-                </a:solidFill>
-                <a:latin typeface="Arial" pitchFamily="34" charset="0"/>
-                <a:ea typeface="Arial" pitchFamily="34" charset="-122"/>
-                <a:cs typeface="Arial" pitchFamily="34" charset="-120"/>
-              </a:rPr>
-              <a:t>18</a:t>
-            </a:r>
-            <a:endParaRPr lang="en-US" sz="1200" dirty="0"/>
+                <a:spcPts val="2100"/>
+              </a:lnSpc>
+              <a:buNone/>
+            </a:pPr>
+            <a:r>
+              <a:rPr lang="en-US" sz="1500" b="1" dirty="0">
+                <a:solidFill>
+                  <a:srgbClr val="3E4A57"/>
+                </a:solidFill>
+                <a:latin typeface="Arial" pitchFamily="34" charset="0"/>
+                <a:ea typeface="Arial" pitchFamily="34" charset="-122"/>
+                <a:cs typeface="Arial" pitchFamily="34" charset="-120"/>
+              </a:rPr>
+              <a:t>18 / 19</a:t>
+            </a:r>
+            <a:endParaRPr lang="en-US" sz="1500" dirty="0"/>
           </a:p>
         </p:txBody>
       </p:sp>
@@ -8106,7 +8106,7 @@
         <p:spPr>
           <a:xfrm>
             <a:off x="812800" y="6238280"/>
-            <a:ext cx="9941560" cy="238720"/>
+            <a:ext cx="9418320" cy="238720"/>
           </a:xfrm>
           <a:prstGeom prst="rect">
             <a:avLst/>
@@ -8149,8 +8149,8 @@
         </p:nvSpPr>
         <p:spPr>
           <a:xfrm>
-            <a:off x="10566400" y="6238280"/>
-            <a:ext cx="812800" cy="238720"/>
+            <a:off x="10058400" y="6210300"/>
+            <a:ext cx="1320800" cy="292100"/>
           </a:xfrm>
           <a:prstGeom prst="rect">
             <a:avLst/>
@@ -8166,22 +8166,22 @@
           <a:p>
             <a:pPr algn="r" indent="0" marL="0">
               <a:lnSpc>
-                <a:spcPts val="1680"/>
-              </a:lnSpc>
-              <a:buNone/>
-            </a:pPr>
-            <a:r>
-              <a:rPr lang="en-US" sz="1200" dirty="0">
-                <a:solidFill>
-                  <a:srgbClr val="5F6A77"/>
-                </a:solidFill>
-                <a:latin typeface="Arial" pitchFamily="34" charset="0"/>
-                <a:ea typeface="Arial" pitchFamily="34" charset="-122"/>
-                <a:cs typeface="Arial" pitchFamily="34" charset="-120"/>
-              </a:rPr>
-              <a:t>19</a:t>
-            </a:r>
-            <a:endParaRPr lang="en-US" sz="1200" dirty="0"/>
+                <a:spcPts val="2100"/>
+              </a:lnSpc>
+              <a:buNone/>
+            </a:pPr>
+            <a:r>
+              <a:rPr lang="en-US" sz="1500" b="1" dirty="0">
+                <a:solidFill>
+                  <a:srgbClr val="3E4A57"/>
+                </a:solidFill>
+                <a:latin typeface="Arial" pitchFamily="34" charset="0"/>
+                <a:ea typeface="Arial" pitchFamily="34" charset="-122"/>
+                <a:cs typeface="Arial" pitchFamily="34" charset="-120"/>
+              </a:rPr>
+              <a:t>19 / 19</a:t>
+            </a:r>
+            <a:endParaRPr lang="en-US" sz="1500" dirty="0"/>
           </a:p>
         </p:txBody>
       </p:sp>
@@ -9071,7 +9071,7 @@
         <p:spPr>
           <a:xfrm>
             <a:off x="812800" y="6238280"/>
-            <a:ext cx="9941560" cy="238720"/>
+            <a:ext cx="9418320" cy="238720"/>
           </a:xfrm>
           <a:prstGeom prst="rect">
             <a:avLst/>
@@ -9114,8 +9114,8 @@
         </p:nvSpPr>
         <p:spPr>
           <a:xfrm>
-            <a:off x="10566400" y="6238280"/>
-            <a:ext cx="812800" cy="238720"/>
+            <a:off x="10058400" y="6210300"/>
+            <a:ext cx="1320800" cy="292100"/>
           </a:xfrm>
           <a:prstGeom prst="rect">
             <a:avLst/>
@@ -9131,22 +9131,22 @@
           <a:p>
             <a:pPr algn="r" indent="0" marL="0">
               <a:lnSpc>
-                <a:spcPts val="1680"/>
-              </a:lnSpc>
-              <a:buNone/>
-            </a:pPr>
-            <a:r>
-              <a:rPr lang="en-US" sz="1200" dirty="0">
-                <a:solidFill>
-                  <a:srgbClr val="5F6A77"/>
-                </a:solidFill>
-                <a:latin typeface="Arial" pitchFamily="34" charset="0"/>
-                <a:ea typeface="Arial" pitchFamily="34" charset="-122"/>
-                <a:cs typeface="Arial" pitchFamily="34" charset="-120"/>
-              </a:rPr>
-              <a:t>2</a:t>
-            </a:r>
-            <a:endParaRPr lang="en-US" sz="1200" dirty="0"/>
+                <a:spcPts val="2100"/>
+              </a:lnSpc>
+              <a:buNone/>
+            </a:pPr>
+            <a:r>
+              <a:rPr lang="en-US" sz="1500" b="1" dirty="0">
+                <a:solidFill>
+                  <a:srgbClr val="3E4A57"/>
+                </a:solidFill>
+                <a:latin typeface="Arial" pitchFamily="34" charset="0"/>
+                <a:ea typeface="Arial" pitchFamily="34" charset="-122"/>
+                <a:cs typeface="Arial" pitchFamily="34" charset="-120"/>
+              </a:rPr>
+              <a:t>2 / 19</a:t>
+            </a:r>
+            <a:endParaRPr lang="en-US" sz="1500" dirty="0"/>
           </a:p>
         </p:txBody>
       </p:sp>
@@ -9649,7 +9649,7 @@
         <p:spPr>
           <a:xfrm>
             <a:off x="812800" y="6238280"/>
-            <a:ext cx="9941560" cy="238720"/>
+            <a:ext cx="9418320" cy="238720"/>
           </a:xfrm>
           <a:prstGeom prst="rect">
             <a:avLst/>
@@ -9692,8 +9692,8 @@
         </p:nvSpPr>
         <p:spPr>
           <a:xfrm>
-            <a:off x="10566400" y="6238280"/>
-            <a:ext cx="812800" cy="238720"/>
+            <a:off x="10058400" y="6210300"/>
+            <a:ext cx="1320800" cy="292100"/>
           </a:xfrm>
           <a:prstGeom prst="rect">
             <a:avLst/>
@@ -9709,22 +9709,22 @@
           <a:p>
             <a:pPr algn="r" indent="0" marL="0">
               <a:lnSpc>
-                <a:spcPts val="1680"/>
-              </a:lnSpc>
-              <a:buNone/>
-            </a:pPr>
-            <a:r>
-              <a:rPr lang="en-US" sz="1200" dirty="0">
-                <a:solidFill>
-                  <a:srgbClr val="5F6A77"/>
-                </a:solidFill>
-                <a:latin typeface="Arial" pitchFamily="34" charset="0"/>
-                <a:ea typeface="Arial" pitchFamily="34" charset="-122"/>
-                <a:cs typeface="Arial" pitchFamily="34" charset="-120"/>
-              </a:rPr>
-              <a:t>3</a:t>
-            </a:r>
-            <a:endParaRPr lang="en-US" sz="1200" dirty="0"/>
+                <a:spcPts val="2100"/>
+              </a:lnSpc>
+              <a:buNone/>
+            </a:pPr>
+            <a:r>
+              <a:rPr lang="en-US" sz="1500" b="1" dirty="0">
+                <a:solidFill>
+                  <a:srgbClr val="3E4A57"/>
+                </a:solidFill>
+                <a:latin typeface="Arial" pitchFamily="34" charset="0"/>
+                <a:ea typeface="Arial" pitchFamily="34" charset="-122"/>
+                <a:cs typeface="Arial" pitchFamily="34" charset="-120"/>
+              </a:rPr>
+              <a:t>3 / 19</a:t>
+            </a:r>
+            <a:endParaRPr lang="en-US" sz="1500" dirty="0"/>
           </a:p>
         </p:txBody>
       </p:sp>
@@ -10509,7 +10509,7 @@
         <p:spPr>
           <a:xfrm>
             <a:off x="812800" y="6238280"/>
-            <a:ext cx="9941560" cy="238720"/>
+            <a:ext cx="9418320" cy="238720"/>
           </a:xfrm>
           <a:prstGeom prst="rect">
             <a:avLst/>
@@ -10552,8 +10552,8 @@
         </p:nvSpPr>
         <p:spPr>
           <a:xfrm>
-            <a:off x="10566400" y="6238280"/>
-            <a:ext cx="812800" cy="238720"/>
+            <a:off x="10058400" y="6210300"/>
+            <a:ext cx="1320800" cy="292100"/>
           </a:xfrm>
           <a:prstGeom prst="rect">
             <a:avLst/>
@@ -10569,22 +10569,22 @@
           <a:p>
             <a:pPr algn="r" indent="0" marL="0">
               <a:lnSpc>
-                <a:spcPts val="1680"/>
-              </a:lnSpc>
-              <a:buNone/>
-            </a:pPr>
-            <a:r>
-              <a:rPr lang="en-US" sz="1200" dirty="0">
-                <a:solidFill>
-                  <a:srgbClr val="5F6A77"/>
-                </a:solidFill>
-                <a:latin typeface="Arial" pitchFamily="34" charset="0"/>
-                <a:ea typeface="Arial" pitchFamily="34" charset="-122"/>
-                <a:cs typeface="Arial" pitchFamily="34" charset="-120"/>
-              </a:rPr>
-              <a:t>4</a:t>
-            </a:r>
-            <a:endParaRPr lang="en-US" sz="1200" dirty="0"/>
+                <a:spcPts val="2100"/>
+              </a:lnSpc>
+              <a:buNone/>
+            </a:pPr>
+            <a:r>
+              <a:rPr lang="en-US" sz="1500" b="1" dirty="0">
+                <a:solidFill>
+                  <a:srgbClr val="3E4A57"/>
+                </a:solidFill>
+                <a:latin typeface="Arial" pitchFamily="34" charset="0"/>
+                <a:ea typeface="Arial" pitchFamily="34" charset="-122"/>
+                <a:cs typeface="Arial" pitchFamily="34" charset="-120"/>
+              </a:rPr>
+              <a:t>4 / 19</a:t>
+            </a:r>
+            <a:endParaRPr lang="en-US" sz="1500" dirty="0"/>
           </a:p>
         </p:txBody>
       </p:sp>
@@ -11001,7 +11001,7 @@
         <p:spPr>
           <a:xfrm>
             <a:off x="812800" y="6238280"/>
-            <a:ext cx="9941560" cy="238720"/>
+            <a:ext cx="9418320" cy="238720"/>
           </a:xfrm>
           <a:prstGeom prst="rect">
             <a:avLst/>
@@ -11044,8 +11044,8 @@
         </p:nvSpPr>
         <p:spPr>
           <a:xfrm>
-            <a:off x="10566400" y="6238280"/>
-            <a:ext cx="812800" cy="238720"/>
+            <a:off x="10058400" y="6210300"/>
+            <a:ext cx="1320800" cy="292100"/>
           </a:xfrm>
           <a:prstGeom prst="rect">
             <a:avLst/>
@@ -11061,22 +11061,22 @@
           <a:p>
             <a:pPr algn="r" indent="0" marL="0">
               <a:lnSpc>
-                <a:spcPts val="1680"/>
-              </a:lnSpc>
-              <a:buNone/>
-            </a:pPr>
-            <a:r>
-              <a:rPr lang="en-US" sz="1200" dirty="0">
-                <a:solidFill>
-                  <a:srgbClr val="5F6A77"/>
-                </a:solidFill>
-                <a:latin typeface="Arial" pitchFamily="34" charset="0"/>
-                <a:ea typeface="Arial" pitchFamily="34" charset="-122"/>
-                <a:cs typeface="Arial" pitchFamily="34" charset="-120"/>
-              </a:rPr>
-              <a:t>5</a:t>
-            </a:r>
-            <a:endParaRPr lang="en-US" sz="1200" dirty="0"/>
+                <a:spcPts val="2100"/>
+              </a:lnSpc>
+              <a:buNone/>
+            </a:pPr>
+            <a:r>
+              <a:rPr lang="en-US" sz="1500" b="1" dirty="0">
+                <a:solidFill>
+                  <a:srgbClr val="3E4A57"/>
+                </a:solidFill>
+                <a:latin typeface="Arial" pitchFamily="34" charset="0"/>
+                <a:ea typeface="Arial" pitchFamily="34" charset="-122"/>
+                <a:cs typeface="Arial" pitchFamily="34" charset="-120"/>
+              </a:rPr>
+              <a:t>5 / 19</a:t>
+            </a:r>
+            <a:endParaRPr lang="en-US" sz="1500" dirty="0"/>
           </a:p>
         </p:txBody>
       </p:sp>
@@ -11515,7 +11515,7 @@
         <p:spPr>
           <a:xfrm>
             <a:off x="812800" y="6238280"/>
-            <a:ext cx="9941560" cy="238720"/>
+            <a:ext cx="9418320" cy="238720"/>
           </a:xfrm>
           <a:prstGeom prst="rect">
             <a:avLst/>
@@ -11558,8 +11558,8 @@
         </p:nvSpPr>
         <p:spPr>
           <a:xfrm>
-            <a:off x="10566400" y="6238280"/>
-            <a:ext cx="812800" cy="238720"/>
+            <a:off x="10058400" y="6210300"/>
+            <a:ext cx="1320800" cy="292100"/>
           </a:xfrm>
           <a:prstGeom prst="rect">
             <a:avLst/>
@@ -11575,22 +11575,22 @@
           <a:p>
             <a:pPr algn="r" indent="0" marL="0">
               <a:lnSpc>
-                <a:spcPts val="1680"/>
-              </a:lnSpc>
-              <a:buNone/>
-            </a:pPr>
-            <a:r>
-              <a:rPr lang="en-US" sz="1200" dirty="0">
-                <a:solidFill>
-                  <a:srgbClr val="5F6A77"/>
-                </a:solidFill>
-                <a:latin typeface="Arial" pitchFamily="34" charset="0"/>
-                <a:ea typeface="Arial" pitchFamily="34" charset="-122"/>
-                <a:cs typeface="Arial" pitchFamily="34" charset="-120"/>
-              </a:rPr>
-              <a:t>6</a:t>
-            </a:r>
-            <a:endParaRPr lang="en-US" sz="1200" dirty="0"/>
+                <a:spcPts val="2100"/>
+              </a:lnSpc>
+              <a:buNone/>
+            </a:pPr>
+            <a:r>
+              <a:rPr lang="en-US" sz="1500" b="1" dirty="0">
+                <a:solidFill>
+                  <a:srgbClr val="3E4A57"/>
+                </a:solidFill>
+                <a:latin typeface="Arial" pitchFamily="34" charset="0"/>
+                <a:ea typeface="Arial" pitchFamily="34" charset="-122"/>
+                <a:cs typeface="Arial" pitchFamily="34" charset="-120"/>
+              </a:rPr>
+              <a:t>6 / 19</a:t>
+            </a:r>
+            <a:endParaRPr lang="en-US" sz="1500" dirty="0"/>
           </a:p>
         </p:txBody>
       </p:sp>
@@ -12063,7 +12063,7 @@
         <p:spPr>
           <a:xfrm>
             <a:off x="812800" y="6238280"/>
-            <a:ext cx="9941560" cy="238720"/>
+            <a:ext cx="9418320" cy="238720"/>
           </a:xfrm>
           <a:prstGeom prst="rect">
             <a:avLst/>
@@ -12106,8 +12106,8 @@
         </p:nvSpPr>
         <p:spPr>
           <a:xfrm>
-            <a:off x="10566400" y="6238280"/>
-            <a:ext cx="812800" cy="238720"/>
+            <a:off x="10058400" y="6210300"/>
+            <a:ext cx="1320800" cy="292100"/>
           </a:xfrm>
           <a:prstGeom prst="rect">
             <a:avLst/>
@@ -12123,22 +12123,22 @@
           <a:p>
             <a:pPr algn="r" indent="0" marL="0">
               <a:lnSpc>
-                <a:spcPts val="1680"/>
-              </a:lnSpc>
-              <a:buNone/>
-            </a:pPr>
-            <a:r>
-              <a:rPr lang="en-US" sz="1200" dirty="0">
-                <a:solidFill>
-                  <a:srgbClr val="5F6A77"/>
-                </a:solidFill>
-                <a:latin typeface="Arial" pitchFamily="34" charset="0"/>
-                <a:ea typeface="Arial" pitchFamily="34" charset="-122"/>
-                <a:cs typeface="Arial" pitchFamily="34" charset="-120"/>
-              </a:rPr>
-              <a:t>7</a:t>
-            </a:r>
-            <a:endParaRPr lang="en-US" sz="1200" dirty="0"/>
+                <a:spcPts val="2100"/>
+              </a:lnSpc>
+              <a:buNone/>
+            </a:pPr>
+            <a:r>
+              <a:rPr lang="en-US" sz="1500" b="1" dirty="0">
+                <a:solidFill>
+                  <a:srgbClr val="3E4A57"/>
+                </a:solidFill>
+                <a:latin typeface="Arial" pitchFamily="34" charset="0"/>
+                <a:ea typeface="Arial" pitchFamily="34" charset="-122"/>
+                <a:cs typeface="Arial" pitchFamily="34" charset="-120"/>
+              </a:rPr>
+              <a:t>7 / 19</a:t>
+            </a:r>
+            <a:endParaRPr lang="en-US" sz="1500" dirty="0"/>
           </a:p>
         </p:txBody>
       </p:sp>
@@ -12609,7 +12609,7 @@
         <p:spPr>
           <a:xfrm>
             <a:off x="812800" y="6238280"/>
-            <a:ext cx="9941560" cy="238720"/>
+            <a:ext cx="9418320" cy="238720"/>
           </a:xfrm>
           <a:prstGeom prst="rect">
             <a:avLst/>
@@ -12652,8 +12652,8 @@
         </p:nvSpPr>
         <p:spPr>
           <a:xfrm>
-            <a:off x="10566400" y="6238280"/>
-            <a:ext cx="812800" cy="238720"/>
+            <a:off x="10058400" y="6210300"/>
+            <a:ext cx="1320800" cy="292100"/>
           </a:xfrm>
           <a:prstGeom prst="rect">
             <a:avLst/>
@@ -12669,22 +12669,22 @@
           <a:p>
             <a:pPr algn="r" indent="0" marL="0">
               <a:lnSpc>
-                <a:spcPts val="1680"/>
-              </a:lnSpc>
-              <a:buNone/>
-            </a:pPr>
-            <a:r>
-              <a:rPr lang="en-US" sz="1200" dirty="0">
-                <a:solidFill>
-                  <a:srgbClr val="5F6A77"/>
-                </a:solidFill>
-                <a:latin typeface="Arial" pitchFamily="34" charset="0"/>
-                <a:ea typeface="Arial" pitchFamily="34" charset="-122"/>
-                <a:cs typeface="Arial" pitchFamily="34" charset="-120"/>
-              </a:rPr>
-              <a:t>8</a:t>
-            </a:r>
-            <a:endParaRPr lang="en-US" sz="1200" dirty="0"/>
+                <a:spcPts val="2100"/>
+              </a:lnSpc>
+              <a:buNone/>
+            </a:pPr>
+            <a:r>
+              <a:rPr lang="en-US" sz="1500" b="1" dirty="0">
+                <a:solidFill>
+                  <a:srgbClr val="3E4A57"/>
+                </a:solidFill>
+                <a:latin typeface="Arial" pitchFamily="34" charset="0"/>
+                <a:ea typeface="Arial" pitchFamily="34" charset="-122"/>
+                <a:cs typeface="Arial" pitchFamily="34" charset="-120"/>
+              </a:rPr>
+              <a:t>8 / 19</a:t>
+            </a:r>
+            <a:endParaRPr lang="en-US" sz="1500" dirty="0"/>
           </a:p>
         </p:txBody>
       </p:sp>
@@ -13156,7 +13156,7 @@
         <p:spPr>
           <a:xfrm>
             <a:off x="812800" y="6238280"/>
-            <a:ext cx="9941560" cy="238720"/>
+            <a:ext cx="9418320" cy="238720"/>
           </a:xfrm>
           <a:prstGeom prst="rect">
             <a:avLst/>
@@ -13199,8 +13199,8 @@
         </p:nvSpPr>
         <p:spPr>
           <a:xfrm>
-            <a:off x="10566400" y="6238280"/>
-            <a:ext cx="812800" cy="238720"/>
+            <a:off x="10058400" y="6210300"/>
+            <a:ext cx="1320800" cy="292100"/>
           </a:xfrm>
           <a:prstGeom prst="rect">
             <a:avLst/>
@@ -13216,22 +13216,22 @@
           <a:p>
             <a:pPr algn="r" indent="0" marL="0">
               <a:lnSpc>
-                <a:spcPts val="1680"/>
-              </a:lnSpc>
-              <a:buNone/>
-            </a:pPr>
-            <a:r>
-              <a:rPr lang="en-US" sz="1200" dirty="0">
-                <a:solidFill>
-                  <a:srgbClr val="5F6A77"/>
-                </a:solidFill>
-                <a:latin typeface="Arial" pitchFamily="34" charset="0"/>
-                <a:ea typeface="Arial" pitchFamily="34" charset="-122"/>
-                <a:cs typeface="Arial" pitchFamily="34" charset="-120"/>
-              </a:rPr>
-              <a:t>9</a:t>
-            </a:r>
-            <a:endParaRPr lang="en-US" sz="1200" dirty="0"/>
+                <a:spcPts val="2100"/>
+              </a:lnSpc>
+              <a:buNone/>
+            </a:pPr>
+            <a:r>
+              <a:rPr lang="en-US" sz="1500" b="1" dirty="0">
+                <a:solidFill>
+                  <a:srgbClr val="3E4A57"/>
+                </a:solidFill>
+                <a:latin typeface="Arial" pitchFamily="34" charset="0"/>
+                <a:ea typeface="Arial" pitchFamily="34" charset="-122"/>
+                <a:cs typeface="Arial" pitchFamily="34" charset="-120"/>
+              </a:rPr>
+              <a:t>9 / 19</a:t>
+            </a:r>
+            <a:endParaRPr lang="en-US" sz="1500" dirty="0"/>
           </a:p>
         </p:txBody>
       </p:sp>

</xml_diff>